<commit_message>
Update Smart_Snake_Robot_SURGE090_Progress_Review  -  Repaired.pptx
</commit_message>
<xml_diff>
--- a/docs/presentations/Smart_Snake_Robot_SURGE090_Progress_Review  -  Repaired.pptx
+++ b/docs/presentations/Smart_Snake_Robot_SURGE090_Progress_Review  -  Repaired.pptx
@@ -5,7 +5,7 @@
     <p:sldMasterId id="2147483648" r:id="rId1"/>
   </p:sldMasterIdLst>
   <p:notesMasterIdLst>
-    <p:notesMasterId r:id="rId15"/>
+    <p:notesMasterId r:id="rId17"/>
   </p:notesMasterIdLst>
   <p:sldIdLst>
     <p:sldId id="287" r:id="rId2"/>
@@ -21,6 +21,8 @@
     <p:sldId id="285" r:id="rId12"/>
     <p:sldId id="268" r:id="rId13"/>
     <p:sldId id="269" r:id="rId14"/>
+    <p:sldId id="308" r:id="rId15"/>
+    <p:sldId id="306" r:id="rId16"/>
   </p:sldIdLst>
   <p:sldSz cx="12192000" cy="6858000"/>
   <p:notesSz cx="6858000" cy="12192000"/>
@@ -1695,7 +1697,7 @@
                   </a:schemeClr>
                 </a:solidFill>
               </a:rPr>
-              <a:t>First Progress Review (Design &amp; Development Phase)</a:t>
+              <a:t>Progress Review (Design &amp; Development)</a:t>
             </a:r>
             <a:endParaRPr lang="en-US" dirty="0">
               <a:solidFill>
@@ -10071,6 +10073,1714 @@
         </p:txBody>
       </p:sp>
     </p:spTree>
+  </p:cSld>
+  <p:clrMapOvr>
+    <a:masterClrMapping/>
+  </p:clrMapOvr>
+</p:sld>
+</file>
+
+<file path=ppt/slides/slide14.xml><?xml version="1.0" encoding="utf-8"?>
+<p:sld xmlns:a="http://schemas.openxmlformats.org/drawingml/2006/main" xmlns:r="http://schemas.openxmlformats.org/officeDocument/2006/relationships" xmlns:p="http://schemas.openxmlformats.org/presentationml/2006/main">
+  <p:cSld>
+    <p:bg>
+      <p:bgPr>
+        <a:solidFill>
+          <a:srgbClr val="F4F6F9"/>
+        </a:solidFill>
+        <a:effectLst/>
+      </p:bgPr>
+    </p:bg>
+    <p:spTree>
+      <p:nvGrpSpPr>
+        <p:cNvPr id="1" name=""/>
+        <p:cNvGrpSpPr/>
+        <p:nvPr/>
+      </p:nvGrpSpPr>
+      <p:grpSpPr>
+        <a:xfrm>
+          <a:off x="0" y="0"/>
+          <a:ext cx="0" cy="0"/>
+          <a:chOff x="0" y="0"/>
+          <a:chExt cx="0" cy="0"/>
+        </a:xfrm>
+      </p:grpSpPr>
+      <p:sp>
+        <p:nvSpPr>
+          <p:cNvPr id="10" name="TopBar"/>
+          <p:cNvSpPr>
+            <a:spLocks noGrp="1"/>
+          </p:cNvSpPr>
+          <p:nvPr/>
+        </p:nvSpPr>
+        <p:spPr>
+          <a:xfrm>
+            <a:off x="0" y="0"/>
+            <a:ext cx="12192000" cy="76200"/>
+          </a:xfrm>
+          <a:prstGeom prst="rect">
+            <a:avLst/>
+          </a:prstGeom>
+          <a:solidFill>
+            <a:srgbClr val="0E96AC"/>
+          </a:solidFill>
+          <a:ln>
+            <a:noFill/>
+          </a:ln>
+        </p:spPr>
+        <p:txBody>
+          <a:bodyPr/>
+          <a:lstStyle/>
+          <a:p>
+            <a:endParaRPr/>
+          </a:p>
+        </p:txBody>
+      </p:sp>
+      <p:sp>
+        <p:nvSpPr>
+          <p:cNvPr id="11" name="Eyebrow"/>
+          <p:cNvSpPr>
+            <a:spLocks noGrp="1"/>
+          </p:cNvSpPr>
+          <p:nvPr/>
+        </p:nvSpPr>
+        <p:spPr>
+          <a:xfrm>
+            <a:off x="533400" y="177800"/>
+            <a:ext cx="8890000" cy="228600"/>
+          </a:xfrm>
+          <a:prstGeom prst="rect">
+            <a:avLst/>
+          </a:prstGeom>
+          <a:noFill/>
+          <a:ln>
+            <a:noFill/>
+          </a:ln>
+        </p:spPr>
+        <p:txBody>
+          <a:bodyPr/>
+          <a:lstStyle/>
+          <a:p>
+            <a:pPr marL="0" indent="0" algn="l">
+              <a:buNone/>
+            </a:pPr>
+            <a:r>
+              <a:rPr lang="en-IN" sz="1100" b="1" dirty="0">
+                <a:solidFill>
+                  <a:srgbClr val="0E96AC"/>
+                </a:solidFill>
+                <a:latin typeface="Calibri" pitchFamily="34" charset="0"/>
+              </a:rPr>
+              <a:t>SIMULATION &amp; VALIDATION</a:t>
+            </a:r>
+          </a:p>
+        </p:txBody>
+      </p:sp>
+      <p:sp>
+        <p:nvSpPr>
+          <p:cNvPr id="12" name="AccentLine"/>
+          <p:cNvSpPr>
+            <a:spLocks noGrp="1"/>
+          </p:cNvSpPr>
+          <p:nvPr/>
+        </p:nvSpPr>
+        <p:spPr>
+          <a:xfrm>
+            <a:off x="533400" y="431800"/>
+            <a:ext cx="11125200" cy="12700"/>
+          </a:xfrm>
+          <a:prstGeom prst="rect">
+            <a:avLst/>
+          </a:prstGeom>
+          <a:solidFill>
+            <a:srgbClr val="0E96AC"/>
+          </a:solidFill>
+          <a:ln>
+            <a:noFill/>
+          </a:ln>
+        </p:spPr>
+        <p:txBody>
+          <a:bodyPr/>
+          <a:lstStyle/>
+          <a:p>
+            <a:endParaRPr/>
+          </a:p>
+        </p:txBody>
+      </p:sp>
+      <p:sp>
+        <p:nvSpPr>
+          <p:cNvPr id="13" name="MainTitle"/>
+          <p:cNvSpPr>
+            <a:spLocks noGrp="1"/>
+          </p:cNvSpPr>
+          <p:nvPr/>
+        </p:nvSpPr>
+        <p:spPr>
+          <a:xfrm>
+            <a:off x="533400" y="508000"/>
+            <a:ext cx="10160000" cy="508000"/>
+          </a:xfrm>
+          <a:prstGeom prst="rect">
+            <a:avLst/>
+          </a:prstGeom>
+          <a:noFill/>
+          <a:ln>
+            <a:noFill/>
+          </a:ln>
+        </p:spPr>
+        <p:txBody>
+          <a:bodyPr/>
+          <a:lstStyle/>
+          <a:p>
+            <a:pPr marL="0" indent="0" algn="l">
+              <a:buNone/>
+            </a:pPr>
+            <a:r>
+              <a:rPr lang="en-IN" sz="2400" b="1" dirty="0">
+                <a:solidFill>
+                  <a:srgbClr val="16223A"/>
+                </a:solidFill>
+                <a:latin typeface="Calibri" pitchFamily="34" charset="0"/>
+              </a:rPr>
+              <a:t>Simulation-Based Validation of Control Architecture</a:t>
+            </a:r>
+          </a:p>
+        </p:txBody>
+      </p:sp>
+      <p:sp>
+        <p:nvSpPr>
+          <p:cNvPr id="20" name="LeftHeader"/>
+          <p:cNvSpPr>
+            <a:spLocks noGrp="1"/>
+          </p:cNvSpPr>
+          <p:nvPr/>
+        </p:nvSpPr>
+        <p:spPr>
+          <a:xfrm>
+            <a:off x="533400" y="1143000"/>
+            <a:ext cx="4191000" cy="279400"/>
+          </a:xfrm>
+          <a:prstGeom prst="rect">
+            <a:avLst/>
+          </a:prstGeom>
+          <a:solidFill>
+            <a:srgbClr val="16223A"/>
+          </a:solidFill>
+          <a:ln>
+            <a:noFill/>
+          </a:ln>
+        </p:spPr>
+        <p:txBody>
+          <a:bodyPr/>
+          <a:lstStyle/>
+          <a:p>
+            <a:pPr marL="0" indent="0" algn="l">
+              <a:buNone/>
+            </a:pPr>
+            <a:r>
+              <a:rPr lang="en-IN" sz="1200" b="1" dirty="0">
+                <a:solidFill>
+                  <a:srgbClr val="FFFFFF"/>
+                </a:solidFill>
+                <a:latin typeface="Calibri" pitchFamily="34" charset="0"/>
+              </a:rPr>
+              <a:t>SYSTEM OVERVIEW</a:t>
+            </a:r>
+          </a:p>
+        </p:txBody>
+      </p:sp>
+      <p:sp>
+        <p:nvSpPr>
+          <p:cNvPr id="21" name="ESP32Block"/>
+          <p:cNvSpPr>
+            <a:spLocks noGrp="1"/>
+          </p:cNvSpPr>
+          <p:nvPr/>
+        </p:nvSpPr>
+        <p:spPr>
+          <a:xfrm>
+            <a:off x="1168400" y="1574800"/>
+            <a:ext cx="2921000" cy="457200"/>
+          </a:xfrm>
+          <a:prstGeom prst="roundRect">
+            <a:avLst>
+              <a:gd name="adj" fmla="val 20000"/>
+            </a:avLst>
+          </a:prstGeom>
+          <a:solidFill>
+            <a:srgbClr val="0E96AC"/>
+          </a:solidFill>
+          <a:ln>
+            <a:noFill/>
+          </a:ln>
+        </p:spPr>
+        <p:txBody>
+          <a:bodyPr/>
+          <a:lstStyle/>
+          <a:p>
+            <a:pPr marL="0" indent="0" algn="ctr">
+              <a:buNone/>
+            </a:pPr>
+            <a:r>
+              <a:rPr lang="en-IN" sz="1400" b="1" dirty="0">
+                <a:solidFill>
+                  <a:srgbClr val="FFFFFF"/>
+                </a:solidFill>
+                <a:latin typeface="Calibri" pitchFamily="34" charset="0"/>
+              </a:rPr>
+              <a:t>ESP32 Controller</a:t>
+            </a:r>
+          </a:p>
+        </p:txBody>
+      </p:sp>
+      <p:sp>
+        <p:nvSpPr>
+          <p:cNvPr id="22" name="Arr1Line"/>
+          <p:cNvSpPr>
+            <a:spLocks noGrp="1"/>
+          </p:cNvSpPr>
+          <p:nvPr/>
+        </p:nvSpPr>
+        <p:spPr>
+          <a:xfrm>
+            <a:off x="2603500" y="2032000"/>
+            <a:ext cx="25400" cy="228600"/>
+          </a:xfrm>
+          <a:prstGeom prst="rect">
+            <a:avLst/>
+          </a:prstGeom>
+          <a:solidFill>
+            <a:srgbClr val="16223A"/>
+          </a:solidFill>
+          <a:ln>
+            <a:noFill/>
+          </a:ln>
+        </p:spPr>
+        <p:txBody>
+          <a:bodyPr/>
+          <a:lstStyle/>
+          <a:p>
+            <a:endParaRPr/>
+          </a:p>
+        </p:txBody>
+      </p:sp>
+      <p:sp>
+        <p:nvSpPr>
+          <p:cNvPr id="23" name="Arr1Head"/>
+          <p:cNvSpPr/>
+          <p:nvPr/>
+        </p:nvSpPr>
+        <p:spPr>
+          <a:xfrm>
+            <a:off x="2540000" y="2235200"/>
+            <a:ext cx="152400" cy="101600"/>
+          </a:xfrm>
+          <a:prstGeom prst="downArrow">
+            <a:avLst>
+              <a:gd name="adj1" fmla="val 50000"/>
+              <a:gd name="adj2" fmla="val 50000"/>
+            </a:avLst>
+          </a:prstGeom>
+          <a:solidFill>
+            <a:srgbClr val="16223A"/>
+          </a:solidFill>
+          <a:ln>
+            <a:noFill/>
+          </a:ln>
+        </p:spPr>
+        <p:txBody>
+          <a:bodyPr/>
+          <a:lstStyle/>
+          <a:p>
+            <a:endParaRPr/>
+          </a:p>
+        </p:txBody>
+      </p:sp>
+      <p:sp>
+        <p:nvSpPr>
+          <p:cNvPr id="24" name="ServoBlock"/>
+          <p:cNvSpPr>
+            <a:spLocks noGrp="1"/>
+          </p:cNvSpPr>
+          <p:nvPr/>
+        </p:nvSpPr>
+        <p:spPr>
+          <a:xfrm>
+            <a:off x="914400" y="2362200"/>
+            <a:ext cx="3429000" cy="457200"/>
+          </a:xfrm>
+          <a:prstGeom prst="roundRect">
+            <a:avLst>
+              <a:gd name="adj" fmla="val 20000"/>
+            </a:avLst>
+          </a:prstGeom>
+          <a:solidFill>
+            <a:srgbClr val="1A3460"/>
+          </a:solidFill>
+          <a:ln>
+            <a:noFill/>
+          </a:ln>
+        </p:spPr>
+        <p:txBody>
+          <a:bodyPr/>
+          <a:lstStyle/>
+          <a:p>
+            <a:pPr marL="0" indent="0" algn="ctr">
+              <a:buNone/>
+            </a:pPr>
+            <a:r>
+              <a:rPr lang="en-IN" sz="1400" b="1" dirty="0">
+                <a:solidFill>
+                  <a:srgbClr val="FFFFFF"/>
+                </a:solidFill>
+                <a:latin typeface="Calibri" pitchFamily="34" charset="0"/>
+              </a:rPr>
+              <a:t>5 Servo Motor Network</a:t>
+            </a:r>
+          </a:p>
+        </p:txBody>
+      </p:sp>
+      <p:sp>
+        <p:nvSpPr>
+          <p:cNvPr id="25" name="ServoSub"/>
+          <p:cNvSpPr>
+            <a:spLocks noGrp="1"/>
+          </p:cNvSpPr>
+          <p:nvPr/>
+        </p:nvSpPr>
+        <p:spPr>
+          <a:xfrm>
+            <a:off x="914400" y="2844800"/>
+            <a:ext cx="3429000" cy="203200"/>
+          </a:xfrm>
+          <a:prstGeom prst="rect">
+            <a:avLst/>
+          </a:prstGeom>
+          <a:noFill/>
+          <a:ln>
+            <a:noFill/>
+          </a:ln>
+        </p:spPr>
+        <p:txBody>
+          <a:bodyPr/>
+          <a:lstStyle/>
+          <a:p>
+            <a:pPr marL="0" indent="0" algn="ctr">
+              <a:buNone/>
+            </a:pPr>
+            <a:r>
+              <a:rPr lang="en-IN" sz="1100" dirty="0">
+                <a:solidFill>
+                  <a:srgbClr val="555E6F"/>
+                </a:solidFill>
+                <a:latin typeface="Calibri" pitchFamily="34" charset="0"/>
+              </a:rPr>
+              <a:t>Joints: S1 – S5 (SG90)</a:t>
+            </a:r>
+          </a:p>
+        </p:txBody>
+      </p:sp>
+      <p:sp>
+        <p:nvSpPr>
+          <p:cNvPr id="26" name="Arr2Line"/>
+          <p:cNvSpPr>
+            <a:spLocks noGrp="1"/>
+          </p:cNvSpPr>
+          <p:nvPr/>
+        </p:nvSpPr>
+        <p:spPr>
+          <a:xfrm>
+            <a:off x="2603500" y="3048000"/>
+            <a:ext cx="25400" cy="228600"/>
+          </a:xfrm>
+          <a:prstGeom prst="rect">
+            <a:avLst/>
+          </a:prstGeom>
+          <a:solidFill>
+            <a:srgbClr val="16223A"/>
+          </a:solidFill>
+          <a:ln>
+            <a:noFill/>
+          </a:ln>
+        </p:spPr>
+        <p:txBody>
+          <a:bodyPr/>
+          <a:lstStyle/>
+          <a:p>
+            <a:endParaRPr/>
+          </a:p>
+        </p:txBody>
+      </p:sp>
+      <p:sp>
+        <p:nvSpPr>
+          <p:cNvPr id="27" name="Arr2Head"/>
+          <p:cNvSpPr/>
+          <p:nvPr/>
+        </p:nvSpPr>
+        <p:spPr>
+          <a:xfrm>
+            <a:off x="2540000" y="3251200"/>
+            <a:ext cx="152400" cy="101600"/>
+          </a:xfrm>
+          <a:prstGeom prst="downArrow">
+            <a:avLst>
+              <a:gd name="adj1" fmla="val 50000"/>
+              <a:gd name="adj2" fmla="val 50000"/>
+            </a:avLst>
+          </a:prstGeom>
+          <a:solidFill>
+            <a:srgbClr val="16223A"/>
+          </a:solidFill>
+          <a:ln>
+            <a:noFill/>
+          </a:ln>
+        </p:spPr>
+        <p:txBody>
+          <a:bodyPr/>
+          <a:lstStyle/>
+          <a:p>
+            <a:endParaRPr/>
+          </a:p>
+        </p:txBody>
+      </p:sp>
+      <p:sp>
+        <p:nvSpPr>
+          <p:cNvPr id="28" name="AlgoBlock"/>
+          <p:cNvSpPr>
+            <a:spLocks noGrp="1"/>
+          </p:cNvSpPr>
+          <p:nvPr/>
+        </p:nvSpPr>
+        <p:spPr>
+          <a:xfrm>
+            <a:off x="914400" y="3378200"/>
+            <a:ext cx="3429000" cy="457200"/>
+          </a:xfrm>
+          <a:prstGeom prst="roundRect">
+            <a:avLst>
+              <a:gd name="adj" fmla="val 20000"/>
+            </a:avLst>
+          </a:prstGeom>
+          <a:solidFill>
+            <a:srgbClr val="0A7A8E"/>
+          </a:solidFill>
+          <a:ln>
+            <a:noFill/>
+          </a:ln>
+        </p:spPr>
+        <p:txBody>
+          <a:bodyPr/>
+          <a:lstStyle/>
+          <a:p>
+            <a:pPr marL="0" indent="0" algn="ctr">
+              <a:buNone/>
+            </a:pPr>
+            <a:r>
+              <a:rPr lang="en-IN" sz="1300" b="1" dirty="0">
+                <a:solidFill>
+                  <a:srgbClr val="FFFFFF"/>
+                </a:solidFill>
+                <a:latin typeface="Calibri" pitchFamily="34" charset="0"/>
+              </a:rPr>
+              <a:t>Serpentine Locomotion Algorithm</a:t>
+            </a:r>
+          </a:p>
+        </p:txBody>
+      </p:sp>
+      <p:sp>
+        <p:nvSpPr>
+          <p:cNvPr id="30" name="SensorHeader"/>
+          <p:cNvSpPr>
+            <a:spLocks noGrp="1"/>
+          </p:cNvSpPr>
+          <p:nvPr/>
+        </p:nvSpPr>
+        <p:spPr>
+          <a:xfrm>
+            <a:off x="533400" y="4064000"/>
+            <a:ext cx="4191000" cy="228600"/>
+          </a:xfrm>
+          <a:prstGeom prst="rect">
+            <a:avLst/>
+          </a:prstGeom>
+          <a:noFill/>
+          <a:ln>
+            <a:noFill/>
+          </a:ln>
+        </p:spPr>
+        <p:txBody>
+          <a:bodyPr/>
+          <a:lstStyle/>
+          <a:p>
+            <a:pPr marL="0" indent="0" algn="l">
+              <a:buNone/>
+            </a:pPr>
+            <a:r>
+              <a:rPr lang="en-IN" sz="1100" b="1" dirty="0">
+                <a:solidFill>
+                  <a:srgbClr val="16223A"/>
+                </a:solidFill>
+                <a:latin typeface="Calibri" pitchFamily="34" charset="0"/>
+              </a:rPr>
+              <a:t>SENSOR MODULES</a:t>
+            </a:r>
+          </a:p>
+        </p:txBody>
+      </p:sp>
+      <p:sp>
+        <p:nvSpPr>
+          <p:cNvPr id="31" name="SensDivider"/>
+          <p:cNvSpPr>
+            <a:spLocks noGrp="1"/>
+          </p:cNvSpPr>
+          <p:nvPr/>
+        </p:nvSpPr>
+        <p:spPr>
+          <a:xfrm>
+            <a:off x="533400" y="4318000"/>
+            <a:ext cx="4191000" cy="12700"/>
+          </a:xfrm>
+          <a:prstGeom prst="rect">
+            <a:avLst/>
+          </a:prstGeom>
+          <a:solidFill>
+            <a:srgbClr val="0E96AC"/>
+          </a:solidFill>
+          <a:ln>
+            <a:noFill/>
+          </a:ln>
+        </p:spPr>
+        <p:txBody>
+          <a:bodyPr/>
+          <a:lstStyle/>
+          <a:p>
+            <a:endParaRPr/>
+          </a:p>
+        </p:txBody>
+      </p:sp>
+      <p:sp>
+        <p:nvSpPr>
+          <p:cNvPr id="32" name="IMUBox"/>
+          <p:cNvSpPr>
+            <a:spLocks noGrp="1"/>
+          </p:cNvSpPr>
+          <p:nvPr/>
+        </p:nvSpPr>
+        <p:spPr>
+          <a:xfrm>
+            <a:off x="533400" y="4394200"/>
+            <a:ext cx="1219200" cy="355600"/>
+          </a:xfrm>
+          <a:prstGeom prst="roundRect">
+            <a:avLst>
+              <a:gd name="adj" fmla="val 20000"/>
+            </a:avLst>
+          </a:prstGeom>
+          <a:solidFill>
+            <a:srgbClr val="E8F5F7"/>
+          </a:solidFill>
+          <a:ln w="9525">
+            <a:solidFill>
+              <a:srgbClr val="0E96AC"/>
+            </a:solidFill>
+          </a:ln>
+        </p:spPr>
+        <p:txBody>
+          <a:bodyPr/>
+          <a:lstStyle/>
+          <a:p>
+            <a:pPr marL="0" indent="0" algn="ctr">
+              <a:buNone/>
+            </a:pPr>
+            <a:r>
+              <a:rPr lang="en-IN" sz="1000" dirty="0">
+                <a:solidFill>
+                  <a:srgbClr val="0A7A8E"/>
+                </a:solidFill>
+                <a:latin typeface="Calibri" pitchFamily="34" charset="0"/>
+              </a:rPr>
+              <a:t>MPU6050 IMU</a:t>
+            </a:r>
+          </a:p>
+        </p:txBody>
+      </p:sp>
+      <p:sp>
+        <p:nvSpPr>
+          <p:cNvPr id="33" name="UltraBox"/>
+          <p:cNvSpPr>
+            <a:spLocks noGrp="1"/>
+          </p:cNvSpPr>
+          <p:nvPr/>
+        </p:nvSpPr>
+        <p:spPr>
+          <a:xfrm>
+            <a:off x="1841500" y="4394200"/>
+            <a:ext cx="1397000" cy="355600"/>
+          </a:xfrm>
+          <a:prstGeom prst="roundRect">
+            <a:avLst>
+              <a:gd name="adj" fmla="val 20000"/>
+            </a:avLst>
+          </a:prstGeom>
+          <a:solidFill>
+            <a:srgbClr val="E8F5F7"/>
+          </a:solidFill>
+          <a:ln w="9525">
+            <a:solidFill>
+              <a:srgbClr val="0E96AC"/>
+            </a:solidFill>
+          </a:ln>
+        </p:spPr>
+        <p:txBody>
+          <a:bodyPr/>
+          <a:lstStyle/>
+          <a:p>
+            <a:pPr marL="0" indent="0" algn="ctr">
+              <a:buNone/>
+            </a:pPr>
+            <a:r>
+              <a:rPr lang="en-IN" sz="1000" dirty="0">
+                <a:solidFill>
+                  <a:srgbClr val="0A7A8E"/>
+                </a:solidFill>
+                <a:latin typeface="Calibri" pitchFamily="34" charset="0"/>
+              </a:rPr>
+              <a:t>HC-SR04 Sonar</a:t>
+            </a:r>
+          </a:p>
+        </p:txBody>
+      </p:sp>
+      <p:sp>
+        <p:nvSpPr>
+          <p:cNvPr id="34" name="OLEDBox"/>
+          <p:cNvSpPr>
+            <a:spLocks noGrp="1"/>
+          </p:cNvSpPr>
+          <p:nvPr/>
+        </p:nvSpPr>
+        <p:spPr>
+          <a:xfrm>
+            <a:off x="3327400" y="4394200"/>
+            <a:ext cx="1397000" cy="355600"/>
+          </a:xfrm>
+          <a:prstGeom prst="roundRect">
+            <a:avLst>
+              <a:gd name="adj" fmla="val 20000"/>
+            </a:avLst>
+          </a:prstGeom>
+          <a:solidFill>
+            <a:srgbClr val="E8F5F7"/>
+          </a:solidFill>
+          <a:ln w="9525">
+            <a:solidFill>
+              <a:srgbClr val="0E96AC"/>
+            </a:solidFill>
+          </a:ln>
+        </p:spPr>
+        <p:txBody>
+          <a:bodyPr/>
+          <a:lstStyle/>
+          <a:p>
+            <a:pPr marL="0" indent="0" algn="ctr">
+              <a:buNone/>
+            </a:pPr>
+            <a:r>
+              <a:rPr lang="en-IN" sz="1000" dirty="0">
+                <a:solidFill>
+                  <a:srgbClr val="0A7A8E"/>
+                </a:solidFill>
+                <a:latin typeface="Calibri" pitchFamily="34" charset="0"/>
+              </a:rPr>
+              <a:t>SSD1306 OLED</a:t>
+            </a:r>
+          </a:p>
+        </p:txBody>
+      </p:sp>
+      <p:sp>
+        <p:nvSpPr>
+          <p:cNvPr id="35" name="NoteBox"/>
+          <p:cNvSpPr>
+            <a:spLocks noGrp="1"/>
+          </p:cNvSpPr>
+          <p:nvPr/>
+        </p:nvSpPr>
+        <p:spPr>
+          <a:xfrm>
+            <a:off x="533400" y="4889500"/>
+            <a:ext cx="4191000" cy="635000"/>
+          </a:xfrm>
+          <a:prstGeom prst="roundRect">
+            <a:avLst>
+              <a:gd name="adj" fmla="val 20000"/>
+            </a:avLst>
+          </a:prstGeom>
+          <a:solidFill>
+            <a:srgbClr val="FFF8E1"/>
+          </a:solidFill>
+          <a:ln w="9525">
+            <a:solidFill>
+              <a:srgbClr val="E6AC00"/>
+            </a:solidFill>
+          </a:ln>
+        </p:spPr>
+        <p:txBody>
+          <a:bodyPr/>
+          <a:lstStyle/>
+          <a:p>
+            <a:pPr marL="0" indent="0" algn="l">
+              <a:buNone/>
+            </a:pPr>
+            <a:r>
+              <a:rPr lang="en-IN" sz="1000" b="1" dirty="0">
+                <a:solidFill>
+                  <a:srgbClr val="B87900"/>
+                </a:solidFill>
+                <a:latin typeface="Calibri" pitchFamily="34" charset="0"/>
+              </a:rPr>
+              <a:t>NOTE</a:t>
+            </a:r>
+          </a:p>
+          <a:p>
+            <a:pPr marL="0" indent="0">
+              <a:buNone/>
+            </a:pPr>
+            <a:r>
+              <a:rPr lang="en-IN" sz="1000" dirty="0">
+                <a:solidFill>
+                  <a:srgbClr val="555E6F"/>
+                </a:solidFill>
+                <a:latin typeface="Calibri" pitchFamily="34" charset="0"/>
+              </a:rPr>
+              <a:t>Simulation platform created to validate software</a:t>
+            </a:r>
+          </a:p>
+          <a:p>
+            <a:pPr marL="0" indent="0">
+              <a:buNone/>
+            </a:pPr>
+            <a:r>
+              <a:rPr lang="en-IN" sz="1000" dirty="0">
+                <a:solidFill>
+                  <a:srgbClr val="555E6F"/>
+                </a:solidFill>
+                <a:latin typeface="Calibri" pitchFamily="34" charset="0"/>
+              </a:rPr>
+              <a:t>architecture before Dynamixel hardware arrival.</a:t>
+            </a:r>
+          </a:p>
+        </p:txBody>
+      </p:sp>
+      <p:sp>
+        <p:nvSpPr>
+          <p:cNvPr id="40" name="ColSep"/>
+          <p:cNvSpPr>
+            <a:spLocks noGrp="1"/>
+          </p:cNvSpPr>
+          <p:nvPr/>
+        </p:nvSpPr>
+        <p:spPr>
+          <a:xfrm>
+            <a:off x="4902200" y="1143000"/>
+            <a:ext cx="12700" cy="4572000"/>
+          </a:xfrm>
+          <a:prstGeom prst="rect">
+            <a:avLst/>
+          </a:prstGeom>
+          <a:solidFill>
+            <a:srgbClr val="D0D7E5"/>
+          </a:solidFill>
+          <a:ln>
+            <a:noFill/>
+          </a:ln>
+        </p:spPr>
+        <p:txBody>
+          <a:bodyPr/>
+          <a:lstStyle/>
+          <a:p>
+            <a:endParaRPr/>
+          </a:p>
+        </p:txBody>
+      </p:sp>
+      <p:sp>
+        <p:nvSpPr>
+          <p:cNvPr id="50" name="RightHeader"/>
+          <p:cNvSpPr>
+            <a:spLocks noGrp="1"/>
+          </p:cNvSpPr>
+          <p:nvPr/>
+        </p:nvSpPr>
+        <p:spPr>
+          <a:xfrm>
+            <a:off x="5029200" y="1143000"/>
+            <a:ext cx="6985000" cy="279400"/>
+          </a:xfrm>
+          <a:prstGeom prst="rect">
+            <a:avLst/>
+          </a:prstGeom>
+          <a:solidFill>
+            <a:srgbClr val="16223A"/>
+          </a:solidFill>
+          <a:ln>
+            <a:noFill/>
+          </a:ln>
+        </p:spPr>
+        <p:txBody>
+          <a:bodyPr/>
+          <a:lstStyle/>
+          <a:p>
+            <a:pPr marL="0" indent="0" algn="l">
+              <a:buNone/>
+            </a:pPr>
+            <a:r>
+              <a:rPr lang="en-IN" sz="1200" b="1" dirty="0">
+                <a:solidFill>
+                  <a:srgbClr val="FFFFFF"/>
+                </a:solidFill>
+                <a:latin typeface="Calibri" pitchFamily="34" charset="0"/>
+              </a:rPr>
+              <a:t>WORK COMPLETED</a:t>
+            </a:r>
+          </a:p>
+        </p:txBody>
+      </p:sp>
+      <p:sp>
+        <p:nvSpPr>
+          <p:cNvPr id="60" name="AchCard0"/>
+          <p:cNvSpPr>
+            <a:spLocks noGrp="1"/>
+          </p:cNvSpPr>
+          <p:nvPr/>
+        </p:nvSpPr>
+        <p:spPr>
+          <a:xfrm>
+            <a:off x="5029200" y="1549400"/>
+            <a:ext cx="6959600" cy="482600"/>
+          </a:xfrm>
+          <a:prstGeom prst="roundRect">
+            <a:avLst>
+              <a:gd name="adj" fmla="val 20000"/>
+            </a:avLst>
+          </a:prstGeom>
+          <a:solidFill>
+            <a:srgbClr val="FFFFFF"/>
+          </a:solidFill>
+          <a:ln w="9525">
+            <a:solidFill>
+              <a:srgbClr val="D0D7E5"/>
+            </a:solidFill>
+          </a:ln>
+        </p:spPr>
+        <p:txBody>
+          <a:bodyPr/>
+          <a:lstStyle/>
+          <a:p>
+            <a:endParaRPr/>
+          </a:p>
+        </p:txBody>
+      </p:sp>
+      <p:sp>
+        <p:nvSpPr>
+          <p:cNvPr id="61" name="AchCheck0"/>
+          <p:cNvSpPr/>
+          <p:nvPr/>
+        </p:nvSpPr>
+        <p:spPr>
+          <a:xfrm>
+            <a:off x="5130800" y="1663700"/>
+            <a:ext cx="254000" cy="254000"/>
+          </a:xfrm>
+          <a:prstGeom prst="ellipse">
+            <a:avLst/>
+          </a:prstGeom>
+          <a:solidFill>
+            <a:srgbClr val="0E96AC"/>
+          </a:solidFill>
+          <a:ln>
+            <a:noFill/>
+          </a:ln>
+        </p:spPr>
+        <p:txBody>
+          <a:bodyPr anchor="ctr" anchorCtr="1">
+            <a:normAutofit fontScale="70000" lnSpcReduction="20000"/>
+          </a:bodyPr>
+          <a:lstStyle/>
+          <a:p>
+            <a:pPr algn="ctr">
+              <a:buNone/>
+            </a:pPr>
+            <a:r>
+              <a:rPr lang="en-IN" sz="1000" b="1" dirty="0">
+                <a:solidFill>
+                  <a:srgbClr val="FFFFFF"/>
+                </a:solidFill>
+                <a:latin typeface="Calibri" pitchFamily="34" charset="0"/>
+              </a:rPr>
+              <a:t>✓</a:t>
+            </a:r>
+          </a:p>
+        </p:txBody>
+      </p:sp>
+      <p:sp>
+        <p:nvSpPr>
+          <p:cNvPr id="62" name="AchText0"/>
+          <p:cNvSpPr>
+            <a:spLocks noGrp="1"/>
+          </p:cNvSpPr>
+          <p:nvPr/>
+        </p:nvSpPr>
+        <p:spPr>
+          <a:xfrm>
+            <a:off x="5486400" y="1612900"/>
+            <a:ext cx="6426200" cy="355600"/>
+          </a:xfrm>
+          <a:prstGeom prst="rect">
+            <a:avLst/>
+          </a:prstGeom>
+          <a:noFill/>
+          <a:ln>
+            <a:noFill/>
+          </a:ln>
+        </p:spPr>
+        <p:txBody>
+          <a:bodyPr/>
+          <a:lstStyle/>
+          <a:p>
+            <a:pPr marL="0" indent="0" algn="l">
+              <a:buNone/>
+            </a:pPr>
+            <a:r>
+              <a:rPr lang="en-IN" sz="1200" dirty="0">
+                <a:solidFill>
+                  <a:srgbClr val="16223A"/>
+                </a:solidFill>
+                <a:latin typeface="Calibri" pitchFamily="34" charset="0"/>
+              </a:rPr>
+              <a:t>Multi-joint locomotion simulation implemented</a:t>
+            </a:r>
+          </a:p>
+        </p:txBody>
+      </p:sp>
+      <p:sp>
+        <p:nvSpPr>
+          <p:cNvPr id="63" name="AchCard1"/>
+          <p:cNvSpPr>
+            <a:spLocks noGrp="1"/>
+          </p:cNvSpPr>
+          <p:nvPr/>
+        </p:nvSpPr>
+        <p:spPr>
+          <a:xfrm>
+            <a:off x="5029200" y="2108200"/>
+            <a:ext cx="6959600" cy="482600"/>
+          </a:xfrm>
+          <a:prstGeom prst="roundRect">
+            <a:avLst>
+              <a:gd name="adj" fmla="val 20000"/>
+            </a:avLst>
+          </a:prstGeom>
+          <a:solidFill>
+            <a:srgbClr val="FFFFFF"/>
+          </a:solidFill>
+          <a:ln w="9525">
+            <a:solidFill>
+              <a:srgbClr val="D0D7E5"/>
+            </a:solidFill>
+          </a:ln>
+        </p:spPr>
+        <p:txBody>
+          <a:bodyPr/>
+          <a:lstStyle/>
+          <a:p>
+            <a:endParaRPr/>
+          </a:p>
+        </p:txBody>
+      </p:sp>
+      <p:sp>
+        <p:nvSpPr>
+          <p:cNvPr id="64" name="AchCheck1"/>
+          <p:cNvSpPr/>
+          <p:nvPr/>
+        </p:nvSpPr>
+        <p:spPr>
+          <a:xfrm>
+            <a:off x="5130800" y="2222500"/>
+            <a:ext cx="254000" cy="254000"/>
+          </a:xfrm>
+          <a:prstGeom prst="ellipse">
+            <a:avLst/>
+          </a:prstGeom>
+          <a:solidFill>
+            <a:srgbClr val="0E96AC"/>
+          </a:solidFill>
+          <a:ln>
+            <a:noFill/>
+          </a:ln>
+        </p:spPr>
+        <p:txBody>
+          <a:bodyPr anchor="ctr" anchorCtr="1">
+            <a:normAutofit fontScale="70000" lnSpcReduction="20000"/>
+          </a:bodyPr>
+          <a:lstStyle/>
+          <a:p>
+            <a:pPr algn="ctr">
+              <a:buNone/>
+            </a:pPr>
+            <a:r>
+              <a:rPr lang="en-IN" sz="1000" b="1" dirty="0">
+                <a:solidFill>
+                  <a:srgbClr val="FFFFFF"/>
+                </a:solidFill>
+                <a:latin typeface="Calibri" pitchFamily="34" charset="0"/>
+              </a:rPr>
+              <a:t>✓</a:t>
+            </a:r>
+          </a:p>
+        </p:txBody>
+      </p:sp>
+      <p:sp>
+        <p:nvSpPr>
+          <p:cNvPr id="65" name="AchText1"/>
+          <p:cNvSpPr>
+            <a:spLocks noGrp="1"/>
+          </p:cNvSpPr>
+          <p:nvPr/>
+        </p:nvSpPr>
+        <p:spPr>
+          <a:xfrm>
+            <a:off x="5486400" y="2171700"/>
+            <a:ext cx="6426200" cy="355600"/>
+          </a:xfrm>
+          <a:prstGeom prst="rect">
+            <a:avLst/>
+          </a:prstGeom>
+          <a:noFill/>
+          <a:ln>
+            <a:noFill/>
+          </a:ln>
+        </p:spPr>
+        <p:txBody>
+          <a:bodyPr/>
+          <a:lstStyle/>
+          <a:p>
+            <a:pPr marL="0" indent="0" algn="l">
+              <a:buNone/>
+            </a:pPr>
+            <a:r>
+              <a:rPr lang="en-IN" sz="1200" dirty="0">
+                <a:solidFill>
+                  <a:srgbClr val="16223A"/>
+                </a:solidFill>
+                <a:latin typeface="Calibri" pitchFamily="34" charset="0"/>
+              </a:rPr>
+              <a:t>Travelling-wave serpentine gait generation developed</a:t>
+            </a:r>
+          </a:p>
+        </p:txBody>
+      </p:sp>
+      <p:sp>
+        <p:nvSpPr>
+          <p:cNvPr id="66" name="AchCard2"/>
+          <p:cNvSpPr>
+            <a:spLocks noGrp="1"/>
+          </p:cNvSpPr>
+          <p:nvPr/>
+        </p:nvSpPr>
+        <p:spPr>
+          <a:xfrm>
+            <a:off x="5029200" y="2667000"/>
+            <a:ext cx="6959600" cy="482600"/>
+          </a:xfrm>
+          <a:prstGeom prst="roundRect">
+            <a:avLst>
+              <a:gd name="adj" fmla="val 20000"/>
+            </a:avLst>
+          </a:prstGeom>
+          <a:solidFill>
+            <a:srgbClr val="FFFFFF"/>
+          </a:solidFill>
+          <a:ln w="9525">
+            <a:solidFill>
+              <a:srgbClr val="D0D7E5"/>
+            </a:solidFill>
+          </a:ln>
+        </p:spPr>
+        <p:txBody>
+          <a:bodyPr/>
+          <a:lstStyle/>
+          <a:p>
+            <a:endParaRPr/>
+          </a:p>
+        </p:txBody>
+      </p:sp>
+      <p:sp>
+        <p:nvSpPr>
+          <p:cNvPr id="67" name="AchCheck2"/>
+          <p:cNvSpPr/>
+          <p:nvPr/>
+        </p:nvSpPr>
+        <p:spPr>
+          <a:xfrm>
+            <a:off x="5130800" y="2781300"/>
+            <a:ext cx="254000" cy="254000"/>
+          </a:xfrm>
+          <a:prstGeom prst="ellipse">
+            <a:avLst/>
+          </a:prstGeom>
+          <a:solidFill>
+            <a:srgbClr val="0E96AC"/>
+          </a:solidFill>
+          <a:ln>
+            <a:noFill/>
+          </a:ln>
+        </p:spPr>
+        <p:txBody>
+          <a:bodyPr anchor="ctr" anchorCtr="1">
+            <a:normAutofit fontScale="70000" lnSpcReduction="20000"/>
+          </a:bodyPr>
+          <a:lstStyle/>
+          <a:p>
+            <a:pPr algn="ctr">
+              <a:buNone/>
+            </a:pPr>
+            <a:r>
+              <a:rPr lang="en-IN" sz="1000" b="1" dirty="0">
+                <a:solidFill>
+                  <a:srgbClr val="FFFFFF"/>
+                </a:solidFill>
+                <a:latin typeface="Calibri" pitchFamily="34" charset="0"/>
+              </a:rPr>
+              <a:t>✓</a:t>
+            </a:r>
+          </a:p>
+        </p:txBody>
+      </p:sp>
+      <p:sp>
+        <p:nvSpPr>
+          <p:cNvPr id="68" name="AchText2"/>
+          <p:cNvSpPr>
+            <a:spLocks noGrp="1"/>
+          </p:cNvSpPr>
+          <p:nvPr/>
+        </p:nvSpPr>
+        <p:spPr>
+          <a:xfrm>
+            <a:off x="5486400" y="2730500"/>
+            <a:ext cx="6426200" cy="355600"/>
+          </a:xfrm>
+          <a:prstGeom prst="rect">
+            <a:avLst/>
+          </a:prstGeom>
+          <a:noFill/>
+          <a:ln>
+            <a:noFill/>
+          </a:ln>
+        </p:spPr>
+        <p:txBody>
+          <a:bodyPr/>
+          <a:lstStyle/>
+          <a:p>
+            <a:pPr marL="0" indent="0" algn="l">
+              <a:buNone/>
+            </a:pPr>
+            <a:r>
+              <a:rPr lang="en-IN" sz="1200" dirty="0">
+                <a:solidFill>
+                  <a:srgbClr val="16223A"/>
+                </a:solidFill>
+                <a:latin typeface="Calibri" pitchFamily="34" charset="0"/>
+              </a:rPr>
+              <a:t>Obstacle detection framework integrated (ultrasonic)</a:t>
+            </a:r>
+          </a:p>
+        </p:txBody>
+      </p:sp>
+      <p:sp>
+        <p:nvSpPr>
+          <p:cNvPr id="69" name="AchCard3"/>
+          <p:cNvSpPr>
+            <a:spLocks noGrp="1"/>
+          </p:cNvSpPr>
+          <p:nvPr/>
+        </p:nvSpPr>
+        <p:spPr>
+          <a:xfrm>
+            <a:off x="5029200" y="3225800"/>
+            <a:ext cx="6959600" cy="482600"/>
+          </a:xfrm>
+          <a:prstGeom prst="roundRect">
+            <a:avLst>
+              <a:gd name="adj" fmla="val 20000"/>
+            </a:avLst>
+          </a:prstGeom>
+          <a:solidFill>
+            <a:srgbClr val="FFFFFF"/>
+          </a:solidFill>
+          <a:ln w="9525">
+            <a:solidFill>
+              <a:srgbClr val="D0D7E5"/>
+            </a:solidFill>
+          </a:ln>
+        </p:spPr>
+        <p:txBody>
+          <a:bodyPr/>
+          <a:lstStyle/>
+          <a:p>
+            <a:endParaRPr/>
+          </a:p>
+        </p:txBody>
+      </p:sp>
+      <p:sp>
+        <p:nvSpPr>
+          <p:cNvPr id="70" name="AchCheck3"/>
+          <p:cNvSpPr/>
+          <p:nvPr/>
+        </p:nvSpPr>
+        <p:spPr>
+          <a:xfrm>
+            <a:off x="5130800" y="3340100"/>
+            <a:ext cx="254000" cy="254000"/>
+          </a:xfrm>
+          <a:prstGeom prst="ellipse">
+            <a:avLst/>
+          </a:prstGeom>
+          <a:solidFill>
+            <a:srgbClr val="0E96AC"/>
+          </a:solidFill>
+          <a:ln>
+            <a:noFill/>
+          </a:ln>
+        </p:spPr>
+        <p:txBody>
+          <a:bodyPr anchor="ctr" anchorCtr="1">
+            <a:normAutofit fontScale="70000" lnSpcReduction="20000"/>
+          </a:bodyPr>
+          <a:lstStyle/>
+          <a:p>
+            <a:pPr algn="ctr">
+              <a:buNone/>
+            </a:pPr>
+            <a:r>
+              <a:rPr lang="en-IN" sz="1000" b="1" dirty="0">
+                <a:solidFill>
+                  <a:srgbClr val="FFFFFF"/>
+                </a:solidFill>
+                <a:latin typeface="Calibri" pitchFamily="34" charset="0"/>
+              </a:rPr>
+              <a:t>✓</a:t>
+            </a:r>
+          </a:p>
+        </p:txBody>
+      </p:sp>
+      <p:sp>
+        <p:nvSpPr>
+          <p:cNvPr id="71" name="AchText3"/>
+          <p:cNvSpPr>
+            <a:spLocks noGrp="1"/>
+          </p:cNvSpPr>
+          <p:nvPr/>
+        </p:nvSpPr>
+        <p:spPr>
+          <a:xfrm>
+            <a:off x="5486400" y="3289300"/>
+            <a:ext cx="6426200" cy="355600"/>
+          </a:xfrm>
+          <a:prstGeom prst="rect">
+            <a:avLst/>
+          </a:prstGeom>
+          <a:noFill/>
+          <a:ln>
+            <a:noFill/>
+          </a:ln>
+        </p:spPr>
+        <p:txBody>
+          <a:bodyPr/>
+          <a:lstStyle/>
+          <a:p>
+            <a:pPr marL="0" indent="0" algn="l">
+              <a:buNone/>
+            </a:pPr>
+            <a:r>
+              <a:rPr lang="en-IN" sz="1200" dirty="0">
+                <a:solidFill>
+                  <a:srgbClr val="16223A"/>
+                </a:solidFill>
+                <a:latin typeface="Calibri" pitchFamily="34" charset="0"/>
+              </a:rPr>
+              <a:t>IMU integration prepared for orientation feedback</a:t>
+            </a:r>
+          </a:p>
+        </p:txBody>
+      </p:sp>
+      <p:sp>
+        <p:nvSpPr>
+          <p:cNvPr id="72" name="AchCard4"/>
+          <p:cNvSpPr>
+            <a:spLocks noGrp="1"/>
+          </p:cNvSpPr>
+          <p:nvPr/>
+        </p:nvSpPr>
+        <p:spPr>
+          <a:xfrm>
+            <a:off x="5029200" y="3784600"/>
+            <a:ext cx="6959600" cy="482600"/>
+          </a:xfrm>
+          <a:prstGeom prst="roundRect">
+            <a:avLst>
+              <a:gd name="adj" fmla="val 20000"/>
+            </a:avLst>
+          </a:prstGeom>
+          <a:solidFill>
+            <a:srgbClr val="FFFFFF"/>
+          </a:solidFill>
+          <a:ln w="9525">
+            <a:solidFill>
+              <a:srgbClr val="D0D7E5"/>
+            </a:solidFill>
+          </a:ln>
+        </p:spPr>
+        <p:txBody>
+          <a:bodyPr/>
+          <a:lstStyle/>
+          <a:p>
+            <a:endParaRPr/>
+          </a:p>
+        </p:txBody>
+      </p:sp>
+      <p:sp>
+        <p:nvSpPr>
+          <p:cNvPr id="73" name="AchCheck4"/>
+          <p:cNvSpPr/>
+          <p:nvPr/>
+        </p:nvSpPr>
+        <p:spPr>
+          <a:xfrm>
+            <a:off x="5130800" y="3898900"/>
+            <a:ext cx="254000" cy="254000"/>
+          </a:xfrm>
+          <a:prstGeom prst="ellipse">
+            <a:avLst/>
+          </a:prstGeom>
+          <a:solidFill>
+            <a:srgbClr val="0E96AC"/>
+          </a:solidFill>
+          <a:ln>
+            <a:noFill/>
+          </a:ln>
+        </p:spPr>
+        <p:txBody>
+          <a:bodyPr anchor="ctr" anchorCtr="1">
+            <a:normAutofit fontScale="70000" lnSpcReduction="20000"/>
+          </a:bodyPr>
+          <a:lstStyle/>
+          <a:p>
+            <a:pPr algn="ctr">
+              <a:buNone/>
+            </a:pPr>
+            <a:r>
+              <a:rPr lang="en-IN" sz="1000" b="1" dirty="0">
+                <a:solidFill>
+                  <a:srgbClr val="FFFFFF"/>
+                </a:solidFill>
+                <a:latin typeface="Calibri" pitchFamily="34" charset="0"/>
+              </a:rPr>
+              <a:t>✓</a:t>
+            </a:r>
+          </a:p>
+        </p:txBody>
+      </p:sp>
+      <p:sp>
+        <p:nvSpPr>
+          <p:cNvPr id="74" name="AchText4"/>
+          <p:cNvSpPr>
+            <a:spLocks noGrp="1"/>
+          </p:cNvSpPr>
+          <p:nvPr/>
+        </p:nvSpPr>
+        <p:spPr>
+          <a:xfrm>
+            <a:off x="5486400" y="3848100"/>
+            <a:ext cx="6426200" cy="355600"/>
+          </a:xfrm>
+          <a:prstGeom prst="rect">
+            <a:avLst/>
+          </a:prstGeom>
+          <a:noFill/>
+          <a:ln>
+            <a:noFill/>
+          </a:ln>
+        </p:spPr>
+        <p:txBody>
+          <a:bodyPr/>
+          <a:lstStyle/>
+          <a:p>
+            <a:pPr marL="0" indent="0" algn="l">
+              <a:buNone/>
+            </a:pPr>
+            <a:r>
+              <a:rPr lang="en-IN" sz="1200" dirty="0">
+                <a:solidFill>
+                  <a:srgbClr val="16223A"/>
+                </a:solidFill>
+                <a:latin typeface="Calibri" pitchFamily="34" charset="0"/>
+              </a:rPr>
+              <a:t>OLED status display integrated</a:t>
+            </a:r>
+          </a:p>
+        </p:txBody>
+      </p:sp>
+      <p:sp>
+        <p:nvSpPr>
+          <p:cNvPr id="75" name="AchCard5"/>
+          <p:cNvSpPr>
+            <a:spLocks noGrp="1"/>
+          </p:cNvSpPr>
+          <p:nvPr/>
+        </p:nvSpPr>
+        <p:spPr>
+          <a:xfrm>
+            <a:off x="5029200" y="4343400"/>
+            <a:ext cx="6959600" cy="482600"/>
+          </a:xfrm>
+          <a:prstGeom prst="roundRect">
+            <a:avLst>
+              <a:gd name="adj" fmla="val 20000"/>
+            </a:avLst>
+          </a:prstGeom>
+          <a:solidFill>
+            <a:srgbClr val="FFFFFF"/>
+          </a:solidFill>
+          <a:ln w="9525">
+            <a:solidFill>
+              <a:srgbClr val="D0D7E5"/>
+            </a:solidFill>
+          </a:ln>
+        </p:spPr>
+        <p:txBody>
+          <a:bodyPr/>
+          <a:lstStyle/>
+          <a:p>
+            <a:endParaRPr/>
+          </a:p>
+        </p:txBody>
+      </p:sp>
+      <p:sp>
+        <p:nvSpPr>
+          <p:cNvPr id="76" name="AchCheck5"/>
+          <p:cNvSpPr/>
+          <p:nvPr/>
+        </p:nvSpPr>
+        <p:spPr>
+          <a:xfrm>
+            <a:off x="5130800" y="4457700"/>
+            <a:ext cx="254000" cy="254000"/>
+          </a:xfrm>
+          <a:prstGeom prst="ellipse">
+            <a:avLst/>
+          </a:prstGeom>
+          <a:solidFill>
+            <a:srgbClr val="0E96AC"/>
+          </a:solidFill>
+          <a:ln>
+            <a:noFill/>
+          </a:ln>
+        </p:spPr>
+        <p:txBody>
+          <a:bodyPr anchor="ctr" anchorCtr="1">
+            <a:normAutofit fontScale="70000" lnSpcReduction="20000"/>
+          </a:bodyPr>
+          <a:lstStyle/>
+          <a:p>
+            <a:pPr algn="ctr">
+              <a:buNone/>
+            </a:pPr>
+            <a:r>
+              <a:rPr lang="en-IN" sz="1000" b="1" dirty="0">
+                <a:solidFill>
+                  <a:srgbClr val="FFFFFF"/>
+                </a:solidFill>
+                <a:latin typeface="Calibri" pitchFamily="34" charset="0"/>
+              </a:rPr>
+              <a:t>✓</a:t>
+            </a:r>
+          </a:p>
+        </p:txBody>
+      </p:sp>
+      <p:sp>
+        <p:nvSpPr>
+          <p:cNvPr id="77" name="AchText5"/>
+          <p:cNvSpPr>
+            <a:spLocks noGrp="1"/>
+          </p:cNvSpPr>
+          <p:nvPr/>
+        </p:nvSpPr>
+        <p:spPr>
+          <a:xfrm>
+            <a:off x="5486400" y="4406900"/>
+            <a:ext cx="6426200" cy="355600"/>
+          </a:xfrm>
+          <a:prstGeom prst="rect">
+            <a:avLst/>
+          </a:prstGeom>
+          <a:noFill/>
+          <a:ln>
+            <a:noFill/>
+          </a:ln>
+        </p:spPr>
+        <p:txBody>
+          <a:bodyPr/>
+          <a:lstStyle/>
+          <a:p>
+            <a:pPr marL="0" indent="0" algn="l">
+              <a:buNone/>
+            </a:pPr>
+            <a:r>
+              <a:rPr lang="en-IN" sz="1200" dirty="0">
+                <a:solidFill>
+                  <a:srgbClr val="16223A"/>
+                </a:solidFill>
+                <a:latin typeface="Calibri" pitchFamily="34" charset="0"/>
+              </a:rPr>
+              <a:t>Modular architecture designed for migration to RPi 5 + Dynamixel XL330</a:t>
+            </a:r>
+          </a:p>
+        </p:txBody>
+      </p:sp>
+      <p:sp>
+        <p:nvSpPr>
+          <p:cNvPr id="100" name="BottomDiv"/>
+          <p:cNvSpPr>
+            <a:spLocks noGrp="1"/>
+          </p:cNvSpPr>
+          <p:nvPr/>
+        </p:nvSpPr>
+        <p:spPr>
+          <a:xfrm>
+            <a:off x="533400" y="5740400"/>
+            <a:ext cx="11125200" cy="12700"/>
+          </a:xfrm>
+          <a:prstGeom prst="rect">
+            <a:avLst/>
+          </a:prstGeom>
+          <a:solidFill>
+            <a:srgbClr val="0E96AC"/>
+          </a:solidFill>
+          <a:ln>
+            <a:noFill/>
+          </a:ln>
+        </p:spPr>
+        <p:txBody>
+          <a:bodyPr/>
+          <a:lstStyle/>
+          <a:p>
+            <a:endParaRPr/>
+          </a:p>
+        </p:txBody>
+      </p:sp>
+      <p:sp>
+        <p:nvSpPr>
+          <p:cNvPr id="101" name="OutcomeBox"/>
+          <p:cNvSpPr>
+            <a:spLocks noGrp="1"/>
+          </p:cNvSpPr>
+          <p:nvPr/>
+        </p:nvSpPr>
+        <p:spPr>
+          <a:xfrm>
+            <a:off x="533400" y="5816600"/>
+            <a:ext cx="11125200" cy="635000"/>
+          </a:xfrm>
+          <a:prstGeom prst="roundRect">
+            <a:avLst>
+              <a:gd name="adj" fmla="val 20000"/>
+            </a:avLst>
+          </a:prstGeom>
+          <a:solidFill>
+            <a:srgbClr val="EAF7FA"/>
+          </a:solidFill>
+          <a:ln w="19050">
+            <a:solidFill>
+              <a:srgbClr val="0E96AC"/>
+            </a:solidFill>
+          </a:ln>
+        </p:spPr>
+        <p:txBody>
+          <a:bodyPr/>
+          <a:lstStyle/>
+          <a:p>
+            <a:pPr marL="0" indent="0">
+              <a:buNone/>
+            </a:pPr>
+            <a:r>
+              <a:rPr lang="en-IN" sz="1000" b="1" dirty="0">
+                <a:solidFill>
+                  <a:srgbClr val="0A7A8E"/>
+                </a:solidFill>
+                <a:latin typeface="Calibri" pitchFamily="34" charset="0"/>
+              </a:rPr>
+              <a:t>KEY OUTCOME  </a:t>
+            </a:r>
+            <a:r>
+              <a:rPr lang="en-IN" sz="1000" dirty="0">
+                <a:solidFill>
+                  <a:srgbClr val="16223A"/>
+                </a:solidFill>
+                <a:latin typeface="Calibri" pitchFamily="34" charset="0"/>
+              </a:rPr>
+              <a:t>A complete software-validation environment established to test locomotion, sensing, and control workflows before physical hardware arrival, reducing future integration risk.</a:t>
+            </a:r>
+          </a:p>
+          <a:p>
+            <a:pPr marL="0" indent="0">
+              <a:buNone/>
+            </a:pPr>
+            <a:r>
+              <a:rPr lang="en-IN" sz="950" i="1" dirty="0">
+                <a:solidFill>
+                  <a:srgbClr val="6B7280"/>
+                </a:solidFill>
+                <a:latin typeface="Calibri" pitchFamily="34" charset="0"/>
+              </a:rPr>
+              <a:t>Simulation-based development enables parallel software progress while Dynamixel actuators and communication hardware remain under procurement.</a:t>
+            </a:r>
+          </a:p>
+        </p:txBody>
+      </p:sp>
+    </p:spTree>
+    <p:extLst>
+      <p:ext uri="{BB962C8B-B14F-4D97-AF65-F5344CB8AC3E}">
+        <p14:creationId xmlns:p14="http://schemas.microsoft.com/office/powerpoint/2010/main" val="1705374684"/>
+      </p:ext>
+    </p:extLst>
+  </p:cSld>
+  <p:clrMapOvr>
+    <a:masterClrMapping/>
+  </p:clrMapOvr>
+</p:sld>
+</file>
+
+<file path=ppt/slides/slide15.xml><?xml version="1.0" encoding="utf-8"?>
+<p:sld xmlns:a="http://schemas.openxmlformats.org/drawingml/2006/main" xmlns:r="http://schemas.openxmlformats.org/officeDocument/2006/relationships" xmlns:p="http://schemas.openxmlformats.org/presentationml/2006/main">
+  <p:cSld>
+    <p:spTree>
+      <p:nvGrpSpPr>
+        <p:cNvPr id="1" name=""/>
+        <p:cNvGrpSpPr/>
+        <p:nvPr/>
+      </p:nvGrpSpPr>
+      <p:grpSpPr>
+        <a:xfrm>
+          <a:off x="0" y="0"/>
+          <a:ext cx="0" cy="0"/>
+          <a:chOff x="0" y="0"/>
+          <a:chExt cx="0" cy="0"/>
+        </a:xfrm>
+      </p:grpSpPr>
+    </p:spTree>
+    <p:extLst>
+      <p:ext uri="{BB962C8B-B14F-4D97-AF65-F5344CB8AC3E}">
+        <p14:creationId xmlns:p14="http://schemas.microsoft.com/office/powerpoint/2010/main" val="3975997946"/>
+      </p:ext>
+    </p:extLst>
   </p:cSld>
   <p:clrMapOvr>
     <a:masterClrMapping/>
@@ -15120,7 +16830,7 @@
                 <a:ea typeface="Calibri" pitchFamily="34" charset="-122"/>
                 <a:cs typeface="Calibri" pitchFamily="34" charset="-120"/>
               </a:rPr>
-              <a:t>OVERALL COMPLETION</a:t>
+              <a:t>OVERALL COMPLETION(till now)</a:t>
             </a:r>
             <a:endParaRPr lang="en-US" sz="1150" dirty="0"/>
           </a:p>

</xml_diff>